<commit_message>
Align Gen5.2 direct selection scoring
</commit_message>
<xml_diff>
--- a/presentations/gen5_2_mechanics_fork.pptx
+++ b/presentations/gen5_2_mechanics_fork.pptx
@@ -2,18 +2,18 @@
 <file path=ppt/presentation.xml><?xml version="1.0" encoding="utf-8"?>
 <p:presentation xmlns:p="http://schemas.openxmlformats.org/presentationml/2006/main">
   <p:sldMasterIdLst>
-    <p:sldMasterId xmlns:r="http://schemas.openxmlformats.org/officeDocument/2006/relationships" id="2147483648" r:id="R56489f519b69428c"/>
+    <p:sldMasterId xmlns:r="http://schemas.openxmlformats.org/officeDocument/2006/relationships" id="2147483648" r:id="Rc598258125ae420b"/>
   </p:sldMasterIdLst>
   <p:notesMasterIdLst>
-    <p:notesMasterId xmlns:r="http://schemas.openxmlformats.org/officeDocument/2006/relationships" r:id="R50e6d85050b747b3"/>
+    <p:notesMasterId xmlns:r="http://schemas.openxmlformats.org/officeDocument/2006/relationships" r:id="R58517ec4179141db"/>
   </p:notesMasterIdLst>
   <p:sldIdLst>
-    <p:sldId xmlns:r="http://schemas.openxmlformats.org/officeDocument/2006/relationships" id="256" r:id="R4830aaa1145741cd"/>
-    <p:sldId xmlns:r="http://schemas.openxmlformats.org/officeDocument/2006/relationships" id="257" r:id="Ra2960ed55d374c0d"/>
-    <p:sldId xmlns:r="http://schemas.openxmlformats.org/officeDocument/2006/relationships" id="258" r:id="Rf5b0217318e34791"/>
-    <p:sldId xmlns:r="http://schemas.openxmlformats.org/officeDocument/2006/relationships" id="259" r:id="R86586f3017e64f09"/>
-    <p:sldId xmlns:r="http://schemas.openxmlformats.org/officeDocument/2006/relationships" id="260" r:id="R6402372af9c5466e"/>
-    <p:sldId xmlns:r="http://schemas.openxmlformats.org/officeDocument/2006/relationships" id="261" r:id="R73643ce273db460e"/>
+    <p:sldId xmlns:r="http://schemas.openxmlformats.org/officeDocument/2006/relationships" id="256" r:id="R05036e90960a4fb7"/>
+    <p:sldId xmlns:r="http://schemas.openxmlformats.org/officeDocument/2006/relationships" id="257" r:id="R48019e7dbf544a63"/>
+    <p:sldId xmlns:r="http://schemas.openxmlformats.org/officeDocument/2006/relationships" id="258" r:id="Rece8300e95564930"/>
+    <p:sldId xmlns:r="http://schemas.openxmlformats.org/officeDocument/2006/relationships" id="259" r:id="R5787e3a43b33440c"/>
+    <p:sldId xmlns:r="http://schemas.openxmlformats.org/officeDocument/2006/relationships" id="260" r:id="R49fbf8d79037476c"/>
+    <p:sldId xmlns:r="http://schemas.openxmlformats.org/officeDocument/2006/relationships" id="261" r:id="R62ae887ffe424d48"/>
   </p:sldIdLst>
   <p:sldSz cx="12192000" cy="6858000"/>
   <p:notesSz cx="6858000" cy="9144000"/>
@@ -936,7 +936,7 @@
   </p:cSld>
   <p:clrMap bg1="lt1" tx1="dk1" bg2="lt2" tx2="dk2" accent1="accent1" accent2="accent2" accent3="accent3" accent4="accent4" accent5="accent5" accent6="accent6" hlink="hlink" folHlink="folHlink"/>
   <p:sldLayoutIdLst>
-    <p:sldLayoutId xmlns:r="http://schemas.openxmlformats.org/officeDocument/2006/relationships" id="2147483649" r:id="Rba17f20dbcf34fc3"/>
+    <p:sldLayoutId xmlns:r="http://schemas.openxmlformats.org/officeDocument/2006/relationships" id="2147483649" r:id="Rb2c918d656394b30"/>
   </p:sldLayoutIdLst>
   <p:txStyles>
     <p:titleStyle>
@@ -1487,7 +1487,7 @@
           <p:cNvPr id="1" name="left-band">
             <a:extLst xmlns:a="http://schemas.openxmlformats.org/drawingml/2006/main">
               <a:ext uri="{FF2B5EF4-FFF2-40B4-BE49-F238E27FC236}">
-                <a16:creationId xmlns:a16="http://schemas.microsoft.com/office/drawing/2014/main" id="{E66C990C-FB3E-4E06-B868-8DB06649C227}"/>
+                <a16:creationId xmlns:a16="http://schemas.microsoft.com/office/drawing/2014/main" id="{29571650-D4D2-472C-B479-688A97612A22}"/>
               </a:ext>
             </a:extLst>
           </p:cNvPr>
@@ -1520,7 +1520,7 @@
           <p:cNvPr id="2" name="kicker">
             <a:extLst xmlns:a="http://schemas.openxmlformats.org/drawingml/2006/main">
               <a:ext uri="{FF2B5EF4-FFF2-40B4-BE49-F238E27FC236}">
-                <a16:creationId xmlns:a16="http://schemas.microsoft.com/office/drawing/2014/main" id="{DE656DD2-BEF8-4761-9CD7-5254B829E395}"/>
+                <a16:creationId xmlns:a16="http://schemas.microsoft.com/office/drawing/2014/main" id="{78B0D152-0B94-4B95-A611-F7511E71023B}"/>
               </a:ext>
             </a:extLst>
           </p:cNvPr>
@@ -1570,7 +1570,7 @@
           <p:cNvPr id="3" name="title">
             <a:extLst xmlns:a="http://schemas.openxmlformats.org/drawingml/2006/main">
               <a:ext uri="{FF2B5EF4-FFF2-40B4-BE49-F238E27FC236}">
-                <a16:creationId xmlns:a16="http://schemas.microsoft.com/office/drawing/2014/main" id="{6A38C433-5812-44CC-B9AF-8FC072736FC5}"/>
+                <a16:creationId xmlns:a16="http://schemas.microsoft.com/office/drawing/2014/main" id="{310F90B1-B8C5-40CC-AF01-CA76A2509566}"/>
               </a:ext>
             </a:extLst>
           </p:cNvPr>
@@ -1620,7 +1620,7 @@
           <p:cNvPr id="4" name="subtitle">
             <a:extLst xmlns:a="http://schemas.openxmlformats.org/drawingml/2006/main">
               <a:ext uri="{FF2B5EF4-FFF2-40B4-BE49-F238E27FC236}">
-                <a16:creationId xmlns:a16="http://schemas.microsoft.com/office/drawing/2014/main" id="{03C07FF6-AF82-4577-8057-5B8950932148}"/>
+                <a16:creationId xmlns:a16="http://schemas.microsoft.com/office/drawing/2014/main" id="{2D52CBD3-CDDC-4A94-ABF1-DC8D7A3656C2}"/>
               </a:ext>
             </a:extLst>
           </p:cNvPr>
@@ -1670,7 +1670,7 @@
           <p:cNvPr id="5" name="branch-box">
             <a:extLst xmlns:a="http://schemas.openxmlformats.org/drawingml/2006/main">
               <a:ext uri="{FF2B5EF4-FFF2-40B4-BE49-F238E27FC236}">
-                <a16:creationId xmlns:a16="http://schemas.microsoft.com/office/drawing/2014/main" id="{9382ED5B-75F5-4C8B-A8B7-C2AAEE81FCB2}"/>
+                <a16:creationId xmlns:a16="http://schemas.microsoft.com/office/drawing/2014/main" id="{42F45C50-06AF-4A60-948C-8A97B1099D15}"/>
               </a:ext>
             </a:extLst>
           </p:cNvPr>
@@ -1703,7 +1703,7 @@
           <p:cNvPr id="6" name="branch">
             <a:extLst xmlns:a="http://schemas.openxmlformats.org/drawingml/2006/main">
               <a:ext uri="{FF2B5EF4-FFF2-40B4-BE49-F238E27FC236}">
-                <a16:creationId xmlns:a16="http://schemas.microsoft.com/office/drawing/2014/main" id="{AFBA6A41-6ABB-4D68-BFEE-D8141AFF7723}"/>
+                <a16:creationId xmlns:a16="http://schemas.microsoft.com/office/drawing/2014/main" id="{9DA71242-0612-476F-AA15-106B527DC9B3}"/>
               </a:ext>
             </a:extLst>
           </p:cNvPr>
@@ -1770,7 +1770,7 @@
           <p:cNvPr id="7" name="footer-left">
             <a:extLst xmlns:a="http://schemas.openxmlformats.org/drawingml/2006/main">
               <a:ext uri="{FF2B5EF4-FFF2-40B4-BE49-F238E27FC236}">
-                <a16:creationId xmlns:a16="http://schemas.microsoft.com/office/drawing/2014/main" id="{ED983B47-1F29-4A1C-AC85-725E01604334}"/>
+                <a16:creationId xmlns:a16="http://schemas.microsoft.com/office/drawing/2014/main" id="{95516254-1B03-4D8B-8E86-1D16EC7DBFBB}"/>
               </a:ext>
             </a:extLst>
           </p:cNvPr>
@@ -1820,7 +1820,7 @@
           <p:cNvPr id="8" name="footer-right">
             <a:extLst xmlns:a="http://schemas.openxmlformats.org/drawingml/2006/main">
               <a:ext uri="{FF2B5EF4-FFF2-40B4-BE49-F238E27FC236}">
-                <a16:creationId xmlns:a16="http://schemas.microsoft.com/office/drawing/2014/main" id="{E793918D-24BA-4F27-BAB3-4E1008404B76}"/>
+                <a16:creationId xmlns:a16="http://schemas.microsoft.com/office/drawing/2014/main" id="{31E735E5-B8FD-4530-B534-E9F5B27CDE28}"/>
               </a:ext>
             </a:extLst>
           </p:cNvPr>
@@ -1868,7 +1868,7 @@
     </p:spTree>
     <p:extLst>
       <p:ext uri="{BB962C8B-B14F-4D97-AF65-F5344CB8AC3E}">
-        <p14:creationId xmlns:p14="http://schemas.microsoft.com/office/powerpoint/2010/main" val="259688104"/>
+        <p14:creationId xmlns:p14="http://schemas.microsoft.com/office/powerpoint/2010/main" val="47181665"/>
       </p:ext>
     </p:extLst>
   </p:cSld>
@@ -1899,7 +1899,7 @@
           <p:cNvPr id="1" name="kicker">
             <a:extLst xmlns:a="http://schemas.openxmlformats.org/drawingml/2006/main">
               <a:ext uri="{FF2B5EF4-FFF2-40B4-BE49-F238E27FC236}">
-                <a16:creationId xmlns:a16="http://schemas.microsoft.com/office/drawing/2014/main" id="{3AC366EE-1003-405D-A85E-D8BB58C60312}"/>
+                <a16:creationId xmlns:a16="http://schemas.microsoft.com/office/drawing/2014/main" id="{0E445C17-D9E6-42C4-B17F-0E8DA95ACB9E}"/>
               </a:ext>
             </a:extLst>
           </p:cNvPr>
@@ -1949,7 +1949,7 @@
           <p:cNvPr id="2" name="slide-title">
             <a:extLst xmlns:a="http://schemas.openxmlformats.org/drawingml/2006/main">
               <a:ext uri="{FF2B5EF4-FFF2-40B4-BE49-F238E27FC236}">
-                <a16:creationId xmlns:a16="http://schemas.microsoft.com/office/drawing/2014/main" id="{D419A35A-BD88-48A5-8F56-2334C7953DCB}"/>
+                <a16:creationId xmlns:a16="http://schemas.microsoft.com/office/drawing/2014/main" id="{61A818E4-2E75-426A-81C9-26EDDA67CF22}"/>
               </a:ext>
             </a:extLst>
           </p:cNvPr>
@@ -1999,7 +1999,7 @@
           <p:cNvPr id="3" name="rule">
             <a:extLst xmlns:a="http://schemas.openxmlformats.org/drawingml/2006/main">
               <a:ext uri="{FF2B5EF4-FFF2-40B4-BE49-F238E27FC236}">
-                <a16:creationId xmlns:a16="http://schemas.microsoft.com/office/drawing/2014/main" id="{1DCE9C4A-5B50-424F-860A-961675E18A7B}"/>
+                <a16:creationId xmlns:a16="http://schemas.microsoft.com/office/drawing/2014/main" id="{2FCB230F-44CC-4BC5-8270-9E87FD7774E1}"/>
               </a:ext>
             </a:extLst>
           </p:cNvPr>
@@ -2032,7 +2032,7 @@
           <p:cNvPr id="4" name="evidence-0">
             <a:extLst xmlns:a="http://schemas.openxmlformats.org/drawingml/2006/main">
               <a:ext uri="{FF2B5EF4-FFF2-40B4-BE49-F238E27FC236}">
-                <a16:creationId xmlns:a16="http://schemas.microsoft.com/office/drawing/2014/main" id="{634A335F-70B2-471A-A76E-4AB1FF990748}"/>
+                <a16:creationId xmlns:a16="http://schemas.microsoft.com/office/drawing/2014/main" id="{E32ADDBD-4850-45CE-97F1-0E425212DCF9}"/>
               </a:ext>
             </a:extLst>
           </p:cNvPr>
@@ -2065,7 +2065,7 @@
           <p:cNvPr id="5" name="evidence-head-0">
             <a:extLst xmlns:a="http://schemas.openxmlformats.org/drawingml/2006/main">
               <a:ext uri="{FF2B5EF4-FFF2-40B4-BE49-F238E27FC236}">
-                <a16:creationId xmlns:a16="http://schemas.microsoft.com/office/drawing/2014/main" id="{5BA548D0-17B8-4371-B2A1-EBE06C4884E5}"/>
+                <a16:creationId xmlns:a16="http://schemas.microsoft.com/office/drawing/2014/main" id="{39F70419-91A1-4223-84DD-EAC7F57C903E}"/>
               </a:ext>
             </a:extLst>
           </p:cNvPr>
@@ -2115,7 +2115,7 @@
           <p:cNvPr id="6" name="evidence-body-0">
             <a:extLst xmlns:a="http://schemas.openxmlformats.org/drawingml/2006/main">
               <a:ext uri="{FF2B5EF4-FFF2-40B4-BE49-F238E27FC236}">
-                <a16:creationId xmlns:a16="http://schemas.microsoft.com/office/drawing/2014/main" id="{2B569CBD-5C27-4C00-AE8A-BCED5B045BC5}"/>
+                <a16:creationId xmlns:a16="http://schemas.microsoft.com/office/drawing/2014/main" id="{07C89B52-A894-422A-8C77-54DC657AC3AE}"/>
               </a:ext>
             </a:extLst>
           </p:cNvPr>
@@ -2165,7 +2165,7 @@
           <p:cNvPr id="7" name="evidence-1">
             <a:extLst xmlns:a="http://schemas.openxmlformats.org/drawingml/2006/main">
               <a:ext uri="{FF2B5EF4-FFF2-40B4-BE49-F238E27FC236}">
-                <a16:creationId xmlns:a16="http://schemas.microsoft.com/office/drawing/2014/main" id="{83D8C8E7-C66E-4D34-8C88-4B301B50C0DB}"/>
+                <a16:creationId xmlns:a16="http://schemas.microsoft.com/office/drawing/2014/main" id="{35D6A2D1-099A-4123-852C-4697952D001A}"/>
               </a:ext>
             </a:extLst>
           </p:cNvPr>
@@ -2198,7 +2198,7 @@
           <p:cNvPr id="8" name="evidence-head-1">
             <a:extLst xmlns:a="http://schemas.openxmlformats.org/drawingml/2006/main">
               <a:ext uri="{FF2B5EF4-FFF2-40B4-BE49-F238E27FC236}">
-                <a16:creationId xmlns:a16="http://schemas.microsoft.com/office/drawing/2014/main" id="{C8D052EC-47E3-40F8-B18F-18CA8EF76F2E}"/>
+                <a16:creationId xmlns:a16="http://schemas.microsoft.com/office/drawing/2014/main" id="{C7241E6B-6E94-40DC-9544-4EC065C8FC2F}"/>
               </a:ext>
             </a:extLst>
           </p:cNvPr>
@@ -2248,7 +2248,7 @@
           <p:cNvPr id="9" name="evidence-body-1">
             <a:extLst xmlns:a="http://schemas.openxmlformats.org/drawingml/2006/main">
               <a:ext uri="{FF2B5EF4-FFF2-40B4-BE49-F238E27FC236}">
-                <a16:creationId xmlns:a16="http://schemas.microsoft.com/office/drawing/2014/main" id="{A1F62422-AB94-4E7A-A20B-57F09AB071F3}"/>
+                <a16:creationId xmlns:a16="http://schemas.microsoft.com/office/drawing/2014/main" id="{1EEE3DA8-2590-4B10-BC01-AAC59863E1D5}"/>
               </a:ext>
             </a:extLst>
           </p:cNvPr>
@@ -2298,7 +2298,7 @@
           <p:cNvPr id="10" name="evidence-2">
             <a:extLst xmlns:a="http://schemas.openxmlformats.org/drawingml/2006/main">
               <a:ext uri="{FF2B5EF4-FFF2-40B4-BE49-F238E27FC236}">
-                <a16:creationId xmlns:a16="http://schemas.microsoft.com/office/drawing/2014/main" id="{407B3F42-B9C1-4D89-9F44-B9F30798DCF0}"/>
+                <a16:creationId xmlns:a16="http://schemas.microsoft.com/office/drawing/2014/main" id="{120C5F5A-8480-40E1-ADD1-02FE80D45296}"/>
               </a:ext>
             </a:extLst>
           </p:cNvPr>
@@ -2331,7 +2331,7 @@
           <p:cNvPr id="11" name="evidence-head-2">
             <a:extLst xmlns:a="http://schemas.openxmlformats.org/drawingml/2006/main">
               <a:ext uri="{FF2B5EF4-FFF2-40B4-BE49-F238E27FC236}">
-                <a16:creationId xmlns:a16="http://schemas.microsoft.com/office/drawing/2014/main" id="{2789CEA9-B8E6-4ABB-A337-61CD4F43495F}"/>
+                <a16:creationId xmlns:a16="http://schemas.microsoft.com/office/drawing/2014/main" id="{D1F58E8D-3F3B-48EE-908E-72F62DB04E23}"/>
               </a:ext>
             </a:extLst>
           </p:cNvPr>
@@ -2381,7 +2381,7 @@
           <p:cNvPr id="12" name="evidence-body-2">
             <a:extLst xmlns:a="http://schemas.openxmlformats.org/drawingml/2006/main">
               <a:ext uri="{FF2B5EF4-FFF2-40B4-BE49-F238E27FC236}">
-                <a16:creationId xmlns:a16="http://schemas.microsoft.com/office/drawing/2014/main" id="{276222F6-8927-4318-8313-FA44E6A0130B}"/>
+                <a16:creationId xmlns:a16="http://schemas.microsoft.com/office/drawing/2014/main" id="{2BF94115-1E4F-47AA-9363-27937513A0B7}"/>
               </a:ext>
             </a:extLst>
           </p:cNvPr>
@@ -2431,7 +2431,7 @@
           <p:cNvPr id="13" name="takeaway-bg">
             <a:extLst xmlns:a="http://schemas.openxmlformats.org/drawingml/2006/main">
               <a:ext uri="{FF2B5EF4-FFF2-40B4-BE49-F238E27FC236}">
-                <a16:creationId xmlns:a16="http://schemas.microsoft.com/office/drawing/2014/main" id="{FA971291-B7EA-492A-951A-E2B6F8D3F0B1}"/>
+                <a16:creationId xmlns:a16="http://schemas.microsoft.com/office/drawing/2014/main" id="{A42F5956-4F5F-4EB0-9B54-BD076A862FDD}"/>
               </a:ext>
             </a:extLst>
           </p:cNvPr>
@@ -2464,7 +2464,7 @@
           <p:cNvPr id="14" name="takeaway">
             <a:extLst xmlns:a="http://schemas.openxmlformats.org/drawingml/2006/main">
               <a:ext uri="{FF2B5EF4-FFF2-40B4-BE49-F238E27FC236}">
-                <a16:creationId xmlns:a16="http://schemas.microsoft.com/office/drawing/2014/main" id="{FA41A750-2A26-45D8-91A9-CBF7FD862919}"/>
+                <a16:creationId xmlns:a16="http://schemas.microsoft.com/office/drawing/2014/main" id="{B6DEDC01-8C46-4DA1-A1C6-2ABF8D2E762E}"/>
               </a:ext>
             </a:extLst>
           </p:cNvPr>
@@ -2514,7 +2514,7 @@
           <p:cNvPr id="15" name="footer-left">
             <a:extLst xmlns:a="http://schemas.openxmlformats.org/drawingml/2006/main">
               <a:ext uri="{FF2B5EF4-FFF2-40B4-BE49-F238E27FC236}">
-                <a16:creationId xmlns:a16="http://schemas.microsoft.com/office/drawing/2014/main" id="{020C319A-9DD7-4E5C-8A92-5DD8E5816635}"/>
+                <a16:creationId xmlns:a16="http://schemas.microsoft.com/office/drawing/2014/main" id="{43A11A55-5DEA-4E6C-A631-501DA01B8124}"/>
               </a:ext>
             </a:extLst>
           </p:cNvPr>
@@ -2564,7 +2564,7 @@
           <p:cNvPr id="16" name="footer-right">
             <a:extLst xmlns:a="http://schemas.openxmlformats.org/drawingml/2006/main">
               <a:ext uri="{FF2B5EF4-FFF2-40B4-BE49-F238E27FC236}">
-                <a16:creationId xmlns:a16="http://schemas.microsoft.com/office/drawing/2014/main" id="{F481E263-D8C4-4D7D-AFF4-48CEF626DCE9}"/>
+                <a16:creationId xmlns:a16="http://schemas.microsoft.com/office/drawing/2014/main" id="{3CD491B5-8EB2-4364-A105-96696F398A98}"/>
               </a:ext>
             </a:extLst>
           </p:cNvPr>
@@ -2612,7 +2612,7 @@
     </p:spTree>
     <p:extLst>
       <p:ext uri="{BB962C8B-B14F-4D97-AF65-F5344CB8AC3E}">
-        <p14:creationId xmlns:p14="http://schemas.microsoft.com/office/powerpoint/2010/main" val="1049201335"/>
+        <p14:creationId xmlns:p14="http://schemas.microsoft.com/office/powerpoint/2010/main" val="1401979624"/>
       </p:ext>
     </p:extLst>
   </p:cSld>
@@ -2643,7 +2643,7 @@
           <p:cNvPr id="1" name="kicker">
             <a:extLst xmlns:a="http://schemas.openxmlformats.org/drawingml/2006/main">
               <a:ext uri="{FF2B5EF4-FFF2-40B4-BE49-F238E27FC236}">
-                <a16:creationId xmlns:a16="http://schemas.microsoft.com/office/drawing/2014/main" id="{B7E4C1F4-B7D7-4888-9681-B0B318DFF461}"/>
+                <a16:creationId xmlns:a16="http://schemas.microsoft.com/office/drawing/2014/main" id="{797E2903-CDBA-4D94-9D67-9C1EC78C3607}"/>
               </a:ext>
             </a:extLst>
           </p:cNvPr>
@@ -2693,7 +2693,7 @@
           <p:cNvPr id="2" name="slide-title">
             <a:extLst xmlns:a="http://schemas.openxmlformats.org/drawingml/2006/main">
               <a:ext uri="{FF2B5EF4-FFF2-40B4-BE49-F238E27FC236}">
-                <a16:creationId xmlns:a16="http://schemas.microsoft.com/office/drawing/2014/main" id="{B1FFDFFF-D3E7-4B50-A39F-6F2C4102E93D}"/>
+                <a16:creationId xmlns:a16="http://schemas.microsoft.com/office/drawing/2014/main" id="{5D3576C5-AD5E-4113-8A2C-ED52D53457A5}"/>
               </a:ext>
             </a:extLst>
           </p:cNvPr>
@@ -2733,7 +2733,7 @@
                   <a:srgbClr val="000000"/>
                 </a:solidFill>
               </a:rPr>
-              <a:t>The pooled-family policy now follows the Gen4 recipe</a:t>
+              <a:t>Both policies now share candidate rules</a:t>
             </a:r>
           </a:p>
         </p:txBody>
@@ -2743,7 +2743,7 @@
           <p:cNvPr id="3" name="rule">
             <a:extLst xmlns:a="http://schemas.openxmlformats.org/drawingml/2006/main">
               <a:ext uri="{FF2B5EF4-FFF2-40B4-BE49-F238E27FC236}">
-                <a16:creationId xmlns:a16="http://schemas.microsoft.com/office/drawing/2014/main" id="{AFDF74A1-1FEB-4EB2-9E28-582B14C40A3A}"/>
+                <a16:creationId xmlns:a16="http://schemas.microsoft.com/office/drawing/2014/main" id="{2BC768B4-75D3-4BB9-9875-DAA049F761B4}"/>
               </a:ext>
             </a:extLst>
           </p:cNvPr>
@@ -2776,7 +2776,7 @@
           <p:cNvPr id="4" name="step-0">
             <a:extLst xmlns:a="http://schemas.openxmlformats.org/drawingml/2006/main">
               <a:ext uri="{FF2B5EF4-FFF2-40B4-BE49-F238E27FC236}">
-                <a16:creationId xmlns:a16="http://schemas.microsoft.com/office/drawing/2014/main" id="{30D057C9-EE69-47C0-80D4-66243A199D7F}"/>
+                <a16:creationId xmlns:a16="http://schemas.microsoft.com/office/drawing/2014/main" id="{40A6FEAE-515D-46FD-AC4E-82F414640B5C}"/>
               </a:ext>
             </a:extLst>
           </p:cNvPr>
@@ -2809,7 +2809,7 @@
           <p:cNvPr id="5" name="num-0">
             <a:extLst xmlns:a="http://schemas.openxmlformats.org/drawingml/2006/main">
               <a:ext uri="{FF2B5EF4-FFF2-40B4-BE49-F238E27FC236}">
-                <a16:creationId xmlns:a16="http://schemas.microsoft.com/office/drawing/2014/main" id="{85ACA6FF-8EAF-4372-9476-2A882B9154F7}"/>
+                <a16:creationId xmlns:a16="http://schemas.microsoft.com/office/drawing/2014/main" id="{31E386B9-C680-47C6-8041-027FDD6AA9AF}"/>
               </a:ext>
             </a:extLst>
           </p:cNvPr>
@@ -2859,7 +2859,7 @@
           <p:cNvPr id="6" name="head-0">
             <a:extLst xmlns:a="http://schemas.openxmlformats.org/drawingml/2006/main">
               <a:ext uri="{FF2B5EF4-FFF2-40B4-BE49-F238E27FC236}">
-                <a16:creationId xmlns:a16="http://schemas.microsoft.com/office/drawing/2014/main" id="{65EB33AE-9C46-4740-895F-CB1625D6D97B}"/>
+                <a16:creationId xmlns:a16="http://schemas.microsoft.com/office/drawing/2014/main" id="{ECF4B452-695D-4E7D-B2D7-F55984E38F12}"/>
               </a:ext>
             </a:extLst>
           </p:cNvPr>
@@ -2909,7 +2909,7 @@
           <p:cNvPr id="7" name="body-0">
             <a:extLst xmlns:a="http://schemas.openxmlformats.org/drawingml/2006/main">
               <a:ext uri="{FF2B5EF4-FFF2-40B4-BE49-F238E27FC236}">
-                <a16:creationId xmlns:a16="http://schemas.microsoft.com/office/drawing/2014/main" id="{2EFB954B-E26E-4D44-8FF3-49537505C0C6}"/>
+                <a16:creationId xmlns:a16="http://schemas.microsoft.com/office/drawing/2014/main" id="{03DBD0C4-F348-4558-BF82-4C99892220B6}"/>
               </a:ext>
             </a:extLst>
           </p:cNvPr>
@@ -2959,7 +2959,7 @@
           <p:cNvPr id="8" name="step-1">
             <a:extLst xmlns:a="http://schemas.openxmlformats.org/drawingml/2006/main">
               <a:ext uri="{FF2B5EF4-FFF2-40B4-BE49-F238E27FC236}">
-                <a16:creationId xmlns:a16="http://schemas.microsoft.com/office/drawing/2014/main" id="{837639E5-5903-4663-A000-CEEAD0F5BCB0}"/>
+                <a16:creationId xmlns:a16="http://schemas.microsoft.com/office/drawing/2014/main" id="{818612EB-3B7A-498C-9D0E-E84331B15294}"/>
               </a:ext>
             </a:extLst>
           </p:cNvPr>
@@ -2992,7 +2992,7 @@
           <p:cNvPr id="9" name="num-1">
             <a:extLst xmlns:a="http://schemas.openxmlformats.org/drawingml/2006/main">
               <a:ext uri="{FF2B5EF4-FFF2-40B4-BE49-F238E27FC236}">
-                <a16:creationId xmlns:a16="http://schemas.microsoft.com/office/drawing/2014/main" id="{FC25721B-981E-4772-B92F-DA7FE2F99C40}"/>
+                <a16:creationId xmlns:a16="http://schemas.microsoft.com/office/drawing/2014/main" id="{69C29348-4CA0-46F0-A0AE-6CD1C0112C32}"/>
               </a:ext>
             </a:extLst>
           </p:cNvPr>
@@ -3042,7 +3042,7 @@
           <p:cNvPr id="10" name="head-1">
             <a:extLst xmlns:a="http://schemas.openxmlformats.org/drawingml/2006/main">
               <a:ext uri="{FF2B5EF4-FFF2-40B4-BE49-F238E27FC236}">
-                <a16:creationId xmlns:a16="http://schemas.microsoft.com/office/drawing/2014/main" id="{28E9753B-4432-452F-8882-CA2991603A5C}"/>
+                <a16:creationId xmlns:a16="http://schemas.microsoft.com/office/drawing/2014/main" id="{EED5CE31-D6D1-45DF-A0E3-EAB62FA32D2F}"/>
               </a:ext>
             </a:extLst>
           </p:cNvPr>
@@ -3092,7 +3092,7 @@
           <p:cNvPr id="11" name="body-1">
             <a:extLst xmlns:a="http://schemas.openxmlformats.org/drawingml/2006/main">
               <a:ext uri="{FF2B5EF4-FFF2-40B4-BE49-F238E27FC236}">
-                <a16:creationId xmlns:a16="http://schemas.microsoft.com/office/drawing/2014/main" id="{140145F1-F2ED-4130-8065-543E322B998C}"/>
+                <a16:creationId xmlns:a16="http://schemas.microsoft.com/office/drawing/2014/main" id="{B7070C7B-4BBD-440F-837D-C2D5ED20F5B5}"/>
               </a:ext>
             </a:extLst>
           </p:cNvPr>
@@ -3142,7 +3142,7 @@
           <p:cNvPr id="12" name="step-2">
             <a:extLst xmlns:a="http://schemas.openxmlformats.org/drawingml/2006/main">
               <a:ext uri="{FF2B5EF4-FFF2-40B4-BE49-F238E27FC236}">
-                <a16:creationId xmlns:a16="http://schemas.microsoft.com/office/drawing/2014/main" id="{907E88AF-DABB-4243-8233-53200040EBCF}"/>
+                <a16:creationId xmlns:a16="http://schemas.microsoft.com/office/drawing/2014/main" id="{6C445C22-717E-43AD-A59C-12B7BE065ED3}"/>
               </a:ext>
             </a:extLst>
           </p:cNvPr>
@@ -3175,7 +3175,7 @@
           <p:cNvPr id="13" name="num-2">
             <a:extLst xmlns:a="http://schemas.openxmlformats.org/drawingml/2006/main">
               <a:ext uri="{FF2B5EF4-FFF2-40B4-BE49-F238E27FC236}">
-                <a16:creationId xmlns:a16="http://schemas.microsoft.com/office/drawing/2014/main" id="{4B68F487-8FAD-4550-AE30-5415E6F9451A}"/>
+                <a16:creationId xmlns:a16="http://schemas.microsoft.com/office/drawing/2014/main" id="{70F6DF32-1A02-4664-A16D-035075F6DF52}"/>
               </a:ext>
             </a:extLst>
           </p:cNvPr>
@@ -3225,7 +3225,7 @@
           <p:cNvPr id="14" name="head-2">
             <a:extLst xmlns:a="http://schemas.openxmlformats.org/drawingml/2006/main">
               <a:ext uri="{FF2B5EF4-FFF2-40B4-BE49-F238E27FC236}">
-                <a16:creationId xmlns:a16="http://schemas.microsoft.com/office/drawing/2014/main" id="{0B171F82-2B16-47AE-AD88-D6A117A57551}"/>
+                <a16:creationId xmlns:a16="http://schemas.microsoft.com/office/drawing/2014/main" id="{B11310AA-017D-42AF-A820-D1EACF9DD58A}"/>
               </a:ext>
             </a:extLst>
           </p:cNvPr>
@@ -3275,7 +3275,7 @@
           <p:cNvPr id="15" name="body-2">
             <a:extLst xmlns:a="http://schemas.openxmlformats.org/drawingml/2006/main">
               <a:ext uri="{FF2B5EF4-FFF2-40B4-BE49-F238E27FC236}">
-                <a16:creationId xmlns:a16="http://schemas.microsoft.com/office/drawing/2014/main" id="{695AA8F1-0ED8-41E0-BAA6-466EBE0DFBF0}"/>
+                <a16:creationId xmlns:a16="http://schemas.microsoft.com/office/drawing/2014/main" id="{9AE6CECB-A501-450A-A2BA-52694E8E28D5}"/>
               </a:ext>
             </a:extLst>
           </p:cNvPr>
@@ -3325,7 +3325,7 @@
           <p:cNvPr id="16" name="step-3">
             <a:extLst xmlns:a="http://schemas.openxmlformats.org/drawingml/2006/main">
               <a:ext uri="{FF2B5EF4-FFF2-40B4-BE49-F238E27FC236}">
-                <a16:creationId xmlns:a16="http://schemas.microsoft.com/office/drawing/2014/main" id="{F470C0FF-C30C-4F19-8B4D-5F5096F711E1}"/>
+                <a16:creationId xmlns:a16="http://schemas.microsoft.com/office/drawing/2014/main" id="{2DF4D7CD-567D-47F1-B2D0-00E6744B8975}"/>
               </a:ext>
             </a:extLst>
           </p:cNvPr>
@@ -3358,7 +3358,7 @@
           <p:cNvPr id="17" name="num-3">
             <a:extLst xmlns:a="http://schemas.openxmlformats.org/drawingml/2006/main">
               <a:ext uri="{FF2B5EF4-FFF2-40B4-BE49-F238E27FC236}">
-                <a16:creationId xmlns:a16="http://schemas.microsoft.com/office/drawing/2014/main" id="{300818EA-BC23-41EE-B00F-AE838F7EE425}"/>
+                <a16:creationId xmlns:a16="http://schemas.microsoft.com/office/drawing/2014/main" id="{AA80B094-32E4-4108-BB0C-A372832A71E0}"/>
               </a:ext>
             </a:extLst>
           </p:cNvPr>
@@ -3408,7 +3408,7 @@
           <p:cNvPr id="18" name="head-3">
             <a:extLst xmlns:a="http://schemas.openxmlformats.org/drawingml/2006/main">
               <a:ext uri="{FF2B5EF4-FFF2-40B4-BE49-F238E27FC236}">
-                <a16:creationId xmlns:a16="http://schemas.microsoft.com/office/drawing/2014/main" id="{A21AE480-F2DC-459A-8455-9DB4B68365E9}"/>
+                <a16:creationId xmlns:a16="http://schemas.microsoft.com/office/drawing/2014/main" id="{D9E93C71-E3F7-4AF2-BDC8-8739812E02AD}"/>
               </a:ext>
             </a:extLst>
           </p:cNvPr>
@@ -3448,7 +3448,7 @@
                   <a:srgbClr val="000000"/>
                 </a:solidFill>
               </a:rPr>
-              <a:t>Pick the family</a:t>
+              <a:t>Direct keeps full specs</a:t>
             </a:r>
           </a:p>
         </p:txBody>
@@ -3458,7 +3458,7 @@
           <p:cNvPr id="19" name="body-3">
             <a:extLst xmlns:a="http://schemas.openxmlformats.org/drawingml/2006/main">
               <a:ext uri="{FF2B5EF4-FFF2-40B4-BE49-F238E27FC236}">
-                <a16:creationId xmlns:a16="http://schemas.microsoft.com/office/drawing/2014/main" id="{6EA71E40-16CA-450B-87EA-14374DD81DF8}"/>
+                <a16:creationId xmlns:a16="http://schemas.microsoft.com/office/drawing/2014/main" id="{2AB9856A-F131-433C-8C7B-DB513ECBCA8F}"/>
               </a:ext>
             </a:extLst>
           </p:cNvPr>
@@ -3498,7 +3498,7 @@
                   <a:srgbClr val="555555"/>
                 </a:solidFill>
               </a:rPr>
-              <a:t>Rank families by mean score, mean return, and evidence breadth.</a:t>
+              <a:t>The direct lane ranks the complete asset/state spec by score then return.</a:t>
             </a:r>
           </a:p>
         </p:txBody>
@@ -3508,7 +3508,7 @@
           <p:cNvPr id="20" name="step-4">
             <a:extLst xmlns:a="http://schemas.openxmlformats.org/drawingml/2006/main">
               <a:ext uri="{FF2B5EF4-FFF2-40B4-BE49-F238E27FC236}">
-                <a16:creationId xmlns:a16="http://schemas.microsoft.com/office/drawing/2014/main" id="{1BD917AD-72DA-4A93-B23E-F33A0A6106B9}"/>
+                <a16:creationId xmlns:a16="http://schemas.microsoft.com/office/drawing/2014/main" id="{11B6101B-9F69-4E4C-9141-E7BCB0250EA5}"/>
               </a:ext>
             </a:extLst>
           </p:cNvPr>
@@ -3541,7 +3541,7 @@
           <p:cNvPr id="21" name="num-4">
             <a:extLst xmlns:a="http://schemas.openxmlformats.org/drawingml/2006/main">
               <a:ext uri="{FF2B5EF4-FFF2-40B4-BE49-F238E27FC236}">
-                <a16:creationId xmlns:a16="http://schemas.microsoft.com/office/drawing/2014/main" id="{3EB02777-382D-4A5E-92A9-BE13FFE8AED3}"/>
+                <a16:creationId xmlns:a16="http://schemas.microsoft.com/office/drawing/2014/main" id="{F6ECC9C6-5116-409A-8C53-B90F7A951F30}"/>
               </a:ext>
             </a:extLst>
           </p:cNvPr>
@@ -3591,7 +3591,7 @@
           <p:cNvPr id="22" name="head-4">
             <a:extLst xmlns:a="http://schemas.openxmlformats.org/drawingml/2006/main">
               <a:ext uri="{FF2B5EF4-FFF2-40B4-BE49-F238E27FC236}">
-                <a16:creationId xmlns:a16="http://schemas.microsoft.com/office/drawing/2014/main" id="{669328C8-B975-4EBF-8AAA-7726905C0EE4}"/>
+                <a16:creationId xmlns:a16="http://schemas.microsoft.com/office/drawing/2014/main" id="{779A277D-84AD-4CC3-B7CE-FBDDD5FAF71C}"/>
               </a:ext>
             </a:extLst>
           </p:cNvPr>
@@ -3631,7 +3631,7 @@
                   <a:srgbClr val="000000"/>
                 </a:solidFill>
               </a:rPr>
-              <a:t>Pick asset params</a:t>
+              <a:t>Pooled keeps family first</a:t>
             </a:r>
           </a:p>
         </p:txBody>
@@ -3641,7 +3641,7 @@
           <p:cNvPr id="23" name="body-4">
             <a:extLst xmlns:a="http://schemas.openxmlformats.org/drawingml/2006/main">
               <a:ext uri="{FF2B5EF4-FFF2-40B4-BE49-F238E27FC236}">
-                <a16:creationId xmlns:a16="http://schemas.microsoft.com/office/drawing/2014/main" id="{3C91F4EF-1F60-4D0E-A94B-9BFEAE0F77ED}"/>
+                <a16:creationId xmlns:a16="http://schemas.microsoft.com/office/drawing/2014/main" id="{14879A20-38EE-4AC4-96D3-00F8A6E3D4CF}"/>
               </a:ext>
             </a:extLst>
           </p:cNvPr>
@@ -3681,7 +3681,7 @@
                   <a:srgbClr val="555555"/>
                 </a:solidFill>
               </a:rPr>
-              <a:t>Within that family, choose the asset-specific variant by score then return.</a:t>
+              <a:t>The pooled lane picks the family first, then asset params inside that family.</a:t>
             </a:r>
           </a:p>
         </p:txBody>
@@ -3691,7 +3691,7 @@
           <p:cNvPr id="24" name="code-note">
             <a:extLst xmlns:a="http://schemas.openxmlformats.org/drawingml/2006/main">
               <a:ext uri="{FF2B5EF4-FFF2-40B4-BE49-F238E27FC236}">
-                <a16:creationId xmlns:a16="http://schemas.microsoft.com/office/drawing/2014/main" id="{628DB34E-E5B8-42DE-9452-23564CD1F7BD}"/>
+                <a16:creationId xmlns:a16="http://schemas.microsoft.com/office/drawing/2014/main" id="{190D2B6B-68AE-40B2-98B0-A3949BB90713}"/>
               </a:ext>
             </a:extLst>
           </p:cNvPr>
@@ -3731,7 +3731,7 @@
                   <a:srgbClr val="555555"/>
                 </a:solidFill>
               </a:rPr>
-              <a:t>Implemented as the public pooled_family_asset_variant policy with selection_policy_recipe = gen4_phase40_pooled_family_asset_variant.</a:t>
+              <a:t>Implemented as shared Gen5.2 eligibility and winner-score logic; only the architecture differs: full-spec direct versus family-first pooled.</a:t>
             </a:r>
           </a:p>
         </p:txBody>
@@ -3741,7 +3741,7 @@
           <p:cNvPr id="25" name="footer-left">
             <a:extLst xmlns:a="http://schemas.openxmlformats.org/drawingml/2006/main">
               <a:ext uri="{FF2B5EF4-FFF2-40B4-BE49-F238E27FC236}">
-                <a16:creationId xmlns:a16="http://schemas.microsoft.com/office/drawing/2014/main" id="{F14CFEE7-E540-4B11-939C-A2CE47E5BC52}"/>
+                <a16:creationId xmlns:a16="http://schemas.microsoft.com/office/drawing/2014/main" id="{70A58865-1496-477E-AE62-FADD3BC543DF}"/>
               </a:ext>
             </a:extLst>
           </p:cNvPr>
@@ -3791,7 +3791,7 @@
           <p:cNvPr id="26" name="footer-right">
             <a:extLst xmlns:a="http://schemas.openxmlformats.org/drawingml/2006/main">
               <a:ext uri="{FF2B5EF4-FFF2-40B4-BE49-F238E27FC236}">
-                <a16:creationId xmlns:a16="http://schemas.microsoft.com/office/drawing/2014/main" id="{40EB799B-086D-4C7F-A40B-F46B357DB9B4}"/>
+                <a16:creationId xmlns:a16="http://schemas.microsoft.com/office/drawing/2014/main" id="{5FDA79B2-D990-4393-BD0C-B4EC75929F4E}"/>
               </a:ext>
             </a:extLst>
           </p:cNvPr>
@@ -3839,7 +3839,7 @@
     </p:spTree>
     <p:extLst>
       <p:ext uri="{BB962C8B-B14F-4D97-AF65-F5344CB8AC3E}">
-        <p14:creationId xmlns:p14="http://schemas.microsoft.com/office/powerpoint/2010/main" val="1762580145"/>
+        <p14:creationId xmlns:p14="http://schemas.microsoft.com/office/powerpoint/2010/main" val="1931440451"/>
       </p:ext>
     </p:extLst>
   </p:cSld>
@@ -3870,7 +3870,7 @@
           <p:cNvPr id="1" name="kicker">
             <a:extLst xmlns:a="http://schemas.openxmlformats.org/drawingml/2006/main">
               <a:ext uri="{FF2B5EF4-FFF2-40B4-BE49-F238E27FC236}">
-                <a16:creationId xmlns:a16="http://schemas.microsoft.com/office/drawing/2014/main" id="{BA3037ED-2957-4CC4-871A-CF647696E029}"/>
+                <a16:creationId xmlns:a16="http://schemas.microsoft.com/office/drawing/2014/main" id="{247E7F13-5099-4858-89C8-5F717856C5CA}"/>
               </a:ext>
             </a:extLst>
           </p:cNvPr>
@@ -3920,7 +3920,7 @@
           <p:cNvPr id="2" name="slide-title">
             <a:extLst xmlns:a="http://schemas.openxmlformats.org/drawingml/2006/main">
               <a:ext uri="{FF2B5EF4-FFF2-40B4-BE49-F238E27FC236}">
-                <a16:creationId xmlns:a16="http://schemas.microsoft.com/office/drawing/2014/main" id="{B014D683-FCDD-4660-9EA9-80BADD266266}"/>
+                <a16:creationId xmlns:a16="http://schemas.microsoft.com/office/drawing/2014/main" id="{717FFF57-49BC-4738-B8F9-6C9F3088D9C7}"/>
               </a:ext>
             </a:extLst>
           </p:cNvPr>
@@ -3970,7 +3970,7 @@
           <p:cNvPr id="3" name="rule">
             <a:extLst xmlns:a="http://schemas.openxmlformats.org/drawingml/2006/main">
               <a:ext uri="{FF2B5EF4-FFF2-40B4-BE49-F238E27FC236}">
-                <a16:creationId xmlns:a16="http://schemas.microsoft.com/office/drawing/2014/main" id="{76586603-4D44-47DF-AC57-22F4B92E82BA}"/>
+                <a16:creationId xmlns:a16="http://schemas.microsoft.com/office/drawing/2014/main" id="{09796799-7ED0-4494-BE51-3D9740F05B4D}"/>
               </a:ext>
             </a:extLst>
           </p:cNvPr>
@@ -4003,7 +4003,7 @@
           <p:cNvPr id="4" name="left-panel">
             <a:extLst xmlns:a="http://schemas.openxmlformats.org/drawingml/2006/main">
               <a:ext uri="{FF2B5EF4-FFF2-40B4-BE49-F238E27FC236}">
-                <a16:creationId xmlns:a16="http://schemas.microsoft.com/office/drawing/2014/main" id="{23A5EC7C-091A-491D-A8D1-7ED2687641A9}"/>
+                <a16:creationId xmlns:a16="http://schemas.microsoft.com/office/drawing/2014/main" id="{0B629D53-40CB-4E8E-B25D-8A6ECC529099}"/>
               </a:ext>
             </a:extLst>
           </p:cNvPr>
@@ -4036,7 +4036,7 @@
           <p:cNvPr id="5" name="right-panel">
             <a:extLst xmlns:a="http://schemas.openxmlformats.org/drawingml/2006/main">
               <a:ext uri="{FF2B5EF4-FFF2-40B4-BE49-F238E27FC236}">
-                <a16:creationId xmlns:a16="http://schemas.microsoft.com/office/drawing/2014/main" id="{27B3E23E-8437-4EA4-89FE-ECA1871FE776}"/>
+                <a16:creationId xmlns:a16="http://schemas.microsoft.com/office/drawing/2014/main" id="{CA80EC72-1BD4-42FA-A068-859B6CBAD8E1}"/>
               </a:ext>
             </a:extLst>
           </p:cNvPr>
@@ -4069,7 +4069,7 @@
           <p:cNvPr id="6" name="left-title">
             <a:extLst xmlns:a="http://schemas.openxmlformats.org/drawingml/2006/main">
               <a:ext uri="{FF2B5EF4-FFF2-40B4-BE49-F238E27FC236}">
-                <a16:creationId xmlns:a16="http://schemas.microsoft.com/office/drawing/2014/main" id="{0F5EE813-E7E8-49D4-9B7C-F07EC30C7795}"/>
+                <a16:creationId xmlns:a16="http://schemas.microsoft.com/office/drawing/2014/main" id="{AFA828A7-9B9F-401B-8248-2C2F53A41E1E}"/>
               </a:ext>
             </a:extLst>
           </p:cNvPr>
@@ -4119,7 +4119,7 @@
           <p:cNvPr id="7" name="left-b-0">
             <a:extLst xmlns:a="http://schemas.openxmlformats.org/drawingml/2006/main">
               <a:ext uri="{FF2B5EF4-FFF2-40B4-BE49-F238E27FC236}">
-                <a16:creationId xmlns:a16="http://schemas.microsoft.com/office/drawing/2014/main" id="{041EBF2D-379C-4DAF-8562-7C2CCD3E0B57}"/>
+                <a16:creationId xmlns:a16="http://schemas.microsoft.com/office/drawing/2014/main" id="{B367F571-7092-4C69-ADD2-67A6F09D6029}"/>
               </a:ext>
             </a:extLst>
           </p:cNvPr>
@@ -4169,7 +4169,7 @@
           <p:cNvPr id="8" name="left-b-1">
             <a:extLst xmlns:a="http://schemas.openxmlformats.org/drawingml/2006/main">
               <a:ext uri="{FF2B5EF4-FFF2-40B4-BE49-F238E27FC236}">
-                <a16:creationId xmlns:a16="http://schemas.microsoft.com/office/drawing/2014/main" id="{3D237F9B-FEAD-44C8-9B7B-5B7317163249}"/>
+                <a16:creationId xmlns:a16="http://schemas.microsoft.com/office/drawing/2014/main" id="{BD31FE69-11EE-4F66-BE93-DD98436873EE}"/>
               </a:ext>
             </a:extLst>
           </p:cNvPr>
@@ -4219,7 +4219,7 @@
           <p:cNvPr id="9" name="left-b-2">
             <a:extLst xmlns:a="http://schemas.openxmlformats.org/drawingml/2006/main">
               <a:ext uri="{FF2B5EF4-FFF2-40B4-BE49-F238E27FC236}">
-                <a16:creationId xmlns:a16="http://schemas.microsoft.com/office/drawing/2014/main" id="{7D4B73E7-62D0-497A-AD9C-797559E58B49}"/>
+                <a16:creationId xmlns:a16="http://schemas.microsoft.com/office/drawing/2014/main" id="{C21B4C6B-3C22-4980-B3BF-F00D12E47051}"/>
               </a:ext>
             </a:extLst>
           </p:cNvPr>
@@ -4269,7 +4269,7 @@
           <p:cNvPr id="10" name="right-title">
             <a:extLst xmlns:a="http://schemas.openxmlformats.org/drawingml/2006/main">
               <a:ext uri="{FF2B5EF4-FFF2-40B4-BE49-F238E27FC236}">
-                <a16:creationId xmlns:a16="http://schemas.microsoft.com/office/drawing/2014/main" id="{B4338A14-C758-44DD-BCB4-0FE7516373B1}"/>
+                <a16:creationId xmlns:a16="http://schemas.microsoft.com/office/drawing/2014/main" id="{78C81779-BE92-4BDF-A958-18F235D05DF7}"/>
               </a:ext>
             </a:extLst>
           </p:cNvPr>
@@ -4319,7 +4319,7 @@
           <p:cNvPr id="11" name="right-b-0">
             <a:extLst xmlns:a="http://schemas.openxmlformats.org/drawingml/2006/main">
               <a:ext uri="{FF2B5EF4-FFF2-40B4-BE49-F238E27FC236}">
-                <a16:creationId xmlns:a16="http://schemas.microsoft.com/office/drawing/2014/main" id="{739241D3-5090-4705-B2BA-682D784533F0}"/>
+                <a16:creationId xmlns:a16="http://schemas.microsoft.com/office/drawing/2014/main" id="{D1A262DA-E978-442B-80F4-ECC0471B26F6}"/>
               </a:ext>
             </a:extLst>
           </p:cNvPr>
@@ -4369,7 +4369,7 @@
           <p:cNvPr id="12" name="right-b-1">
             <a:extLst xmlns:a="http://schemas.openxmlformats.org/drawingml/2006/main">
               <a:ext uri="{FF2B5EF4-FFF2-40B4-BE49-F238E27FC236}">
-                <a16:creationId xmlns:a16="http://schemas.microsoft.com/office/drawing/2014/main" id="{F62A97F9-A3DF-410C-988F-11C0E69D04CA}"/>
+                <a16:creationId xmlns:a16="http://schemas.microsoft.com/office/drawing/2014/main" id="{F3428FC1-F5E8-43E3-860F-F742B687657C}"/>
               </a:ext>
             </a:extLst>
           </p:cNvPr>
@@ -4419,7 +4419,7 @@
           <p:cNvPr id="13" name="right-b-2">
             <a:extLst xmlns:a="http://schemas.openxmlformats.org/drawingml/2006/main">
               <a:ext uri="{FF2B5EF4-FFF2-40B4-BE49-F238E27FC236}">
-                <a16:creationId xmlns:a16="http://schemas.microsoft.com/office/drawing/2014/main" id="{FE376E62-FDD7-4892-9340-F2D90EAF46C1}"/>
+                <a16:creationId xmlns:a16="http://schemas.microsoft.com/office/drawing/2014/main" id="{A683EDA7-647D-40EC-9FFF-4533CDB3996E}"/>
               </a:ext>
             </a:extLst>
           </p:cNvPr>
@@ -4469,7 +4469,7 @@
           <p:cNvPr id="14" name="rule">
             <a:extLst xmlns:a="http://schemas.openxmlformats.org/drawingml/2006/main">
               <a:ext uri="{FF2B5EF4-FFF2-40B4-BE49-F238E27FC236}">
-                <a16:creationId xmlns:a16="http://schemas.microsoft.com/office/drawing/2014/main" id="{AB17ADD9-ECC9-4EF8-894C-41CD308A15ED}"/>
+                <a16:creationId xmlns:a16="http://schemas.microsoft.com/office/drawing/2014/main" id="{FC924D24-8546-4E6C-932D-10476722BC7F}"/>
               </a:ext>
             </a:extLst>
           </p:cNvPr>
@@ -4502,7 +4502,7 @@
           <p:cNvPr id="15" name="bottom">
             <a:extLst xmlns:a="http://schemas.openxmlformats.org/drawingml/2006/main">
               <a:ext uri="{FF2B5EF4-FFF2-40B4-BE49-F238E27FC236}">
-                <a16:creationId xmlns:a16="http://schemas.microsoft.com/office/drawing/2014/main" id="{7071615E-9F10-4A3D-940E-9E9CEF322606}"/>
+                <a16:creationId xmlns:a16="http://schemas.microsoft.com/office/drawing/2014/main" id="{395FE2BE-6FAC-4A5F-BB56-1F4D73207AB5}"/>
               </a:ext>
             </a:extLst>
           </p:cNvPr>
@@ -4552,7 +4552,7 @@
           <p:cNvPr id="16" name="footer-left">
             <a:extLst xmlns:a="http://schemas.openxmlformats.org/drawingml/2006/main">
               <a:ext uri="{FF2B5EF4-FFF2-40B4-BE49-F238E27FC236}">
-                <a16:creationId xmlns:a16="http://schemas.microsoft.com/office/drawing/2014/main" id="{601342EF-C6BF-4E0E-A225-1106EA6C356A}"/>
+                <a16:creationId xmlns:a16="http://schemas.microsoft.com/office/drawing/2014/main" id="{DD0F583D-8ECA-4048-AA57-B2845D99289A}"/>
               </a:ext>
             </a:extLst>
           </p:cNvPr>
@@ -4602,7 +4602,7 @@
           <p:cNvPr id="17" name="footer-right">
             <a:extLst xmlns:a="http://schemas.openxmlformats.org/drawingml/2006/main">
               <a:ext uri="{FF2B5EF4-FFF2-40B4-BE49-F238E27FC236}">
-                <a16:creationId xmlns:a16="http://schemas.microsoft.com/office/drawing/2014/main" id="{D01B2638-7171-439F-91BE-D37BD510456B}"/>
+                <a16:creationId xmlns:a16="http://schemas.microsoft.com/office/drawing/2014/main" id="{AB97E2F6-ECC7-4A9D-83A8-819706C22976}"/>
               </a:ext>
             </a:extLst>
           </p:cNvPr>
@@ -4650,7 +4650,7 @@
     </p:spTree>
     <p:extLst>
       <p:ext uri="{BB962C8B-B14F-4D97-AF65-F5344CB8AC3E}">
-        <p14:creationId xmlns:p14="http://schemas.microsoft.com/office/powerpoint/2010/main" val="1092830508"/>
+        <p14:creationId xmlns:p14="http://schemas.microsoft.com/office/powerpoint/2010/main" val="1047999805"/>
       </p:ext>
     </p:extLst>
   </p:cSld>
@@ -4681,7 +4681,7 @@
           <p:cNvPr id="1" name="kicker">
             <a:extLst xmlns:a="http://schemas.openxmlformats.org/drawingml/2006/main">
               <a:ext uri="{FF2B5EF4-FFF2-40B4-BE49-F238E27FC236}">
-                <a16:creationId xmlns:a16="http://schemas.microsoft.com/office/drawing/2014/main" id="{2EFCFD38-8E1E-4901-B79F-C05BB16A5143}"/>
+                <a16:creationId xmlns:a16="http://schemas.microsoft.com/office/drawing/2014/main" id="{A398A958-8986-43BE-98E2-D0E2E40FA758}"/>
               </a:ext>
             </a:extLst>
           </p:cNvPr>
@@ -4731,7 +4731,7 @@
           <p:cNvPr id="2" name="slide-title">
             <a:extLst xmlns:a="http://schemas.openxmlformats.org/drawingml/2006/main">
               <a:ext uri="{FF2B5EF4-FFF2-40B4-BE49-F238E27FC236}">
-                <a16:creationId xmlns:a16="http://schemas.microsoft.com/office/drawing/2014/main" id="{3D1F3EB2-4B6B-413C-9C74-26C824D777F4}"/>
+                <a16:creationId xmlns:a16="http://schemas.microsoft.com/office/drawing/2014/main" id="{AC4C6954-F3BE-4777-8BF0-811649B0E7FF}"/>
               </a:ext>
             </a:extLst>
           </p:cNvPr>
@@ -4781,7 +4781,7 @@
           <p:cNvPr id="3" name="rule">
             <a:extLst xmlns:a="http://schemas.openxmlformats.org/drawingml/2006/main">
               <a:ext uri="{FF2B5EF4-FFF2-40B4-BE49-F238E27FC236}">
-                <a16:creationId xmlns:a16="http://schemas.microsoft.com/office/drawing/2014/main" id="{05C6B1FD-DFD3-4A41-8D9C-6EB9CA95F426}"/>
+                <a16:creationId xmlns:a16="http://schemas.microsoft.com/office/drawing/2014/main" id="{251D4A22-C104-4800-AAE5-4AF9684E91A8}"/>
               </a:ext>
             </a:extLst>
           </p:cNvPr>
@@ -4814,7 +4814,7 @@
           <p:cNvPr id="4" name="proxy">
             <a:extLst xmlns:a="http://schemas.openxmlformats.org/drawingml/2006/main">
               <a:ext uri="{FF2B5EF4-FFF2-40B4-BE49-F238E27FC236}">
-                <a16:creationId xmlns:a16="http://schemas.microsoft.com/office/drawing/2014/main" id="{03E6F188-604A-4C1D-83BA-C8EE793BA890}"/>
+                <a16:creationId xmlns:a16="http://schemas.microsoft.com/office/drawing/2014/main" id="{5321F90F-8F10-4276-B43A-2E1DBC46BBD4}"/>
               </a:ext>
             </a:extLst>
           </p:cNvPr>
@@ -4847,7 +4847,7 @@
           <p:cNvPr id="5" name="live">
             <a:extLst xmlns:a="http://schemas.openxmlformats.org/drawingml/2006/main">
               <a:ext uri="{FF2B5EF4-FFF2-40B4-BE49-F238E27FC236}">
-                <a16:creationId xmlns:a16="http://schemas.microsoft.com/office/drawing/2014/main" id="{2351E862-2EF3-469F-8CF2-1342BA46CD53}"/>
+                <a16:creationId xmlns:a16="http://schemas.microsoft.com/office/drawing/2014/main" id="{F97786DB-EECE-4173-A38E-EDE98B083F56}"/>
               </a:ext>
             </a:extLst>
           </p:cNvPr>
@@ -4880,7 +4880,7 @@
           <p:cNvPr id="6" name="proxy-pill-bg">
             <a:extLst xmlns:a="http://schemas.openxmlformats.org/drawingml/2006/main">
               <a:ext uri="{FF2B5EF4-FFF2-40B4-BE49-F238E27FC236}">
-                <a16:creationId xmlns:a16="http://schemas.microsoft.com/office/drawing/2014/main" id="{44C5DC93-A419-41CD-86F2-A72FDBADBED3}"/>
+                <a16:creationId xmlns:a16="http://schemas.microsoft.com/office/drawing/2014/main" id="{144945B5-39DC-4EE4-9CED-B8829DA92745}"/>
               </a:ext>
             </a:extLst>
           </p:cNvPr>
@@ -4913,7 +4913,7 @@
           <p:cNvPr id="7" name="proxy-pill-txt">
             <a:extLst xmlns:a="http://schemas.openxmlformats.org/drawingml/2006/main">
               <a:ext uri="{FF2B5EF4-FFF2-40B4-BE49-F238E27FC236}">
-                <a16:creationId xmlns:a16="http://schemas.microsoft.com/office/drawing/2014/main" id="{DEE06A2F-A119-455C-AC27-3516B3C3EA46}"/>
+                <a16:creationId xmlns:a16="http://schemas.microsoft.com/office/drawing/2014/main" id="{BA65C0B3-F2A6-484D-88E6-3F1C126D3C41}"/>
               </a:ext>
             </a:extLst>
           </p:cNvPr>
@@ -4963,7 +4963,7 @@
           <p:cNvPr id="8" name="proxy-title">
             <a:extLst xmlns:a="http://schemas.openxmlformats.org/drawingml/2006/main">
               <a:ext uri="{FF2B5EF4-FFF2-40B4-BE49-F238E27FC236}">
-                <a16:creationId xmlns:a16="http://schemas.microsoft.com/office/drawing/2014/main" id="{C605CA05-AE10-40CF-BBC3-5959D087DD21}"/>
+                <a16:creationId xmlns:a16="http://schemas.microsoft.com/office/drawing/2014/main" id="{BFAB1BC6-C34A-47FB-BCBB-1F78FA161F3A}"/>
               </a:ext>
             </a:extLst>
           </p:cNvPr>
@@ -5013,7 +5013,7 @@
           <p:cNvPr id="9" name="proxy-b-0">
             <a:extLst xmlns:a="http://schemas.openxmlformats.org/drawingml/2006/main">
               <a:ext uri="{FF2B5EF4-FFF2-40B4-BE49-F238E27FC236}">
-                <a16:creationId xmlns:a16="http://schemas.microsoft.com/office/drawing/2014/main" id="{7261E7C8-22C9-4793-B996-EB317EAFCA83}"/>
+                <a16:creationId xmlns:a16="http://schemas.microsoft.com/office/drawing/2014/main" id="{DD750650-E7B2-4F9D-A799-D2BB5F93EBBD}"/>
               </a:ext>
             </a:extLst>
           </p:cNvPr>
@@ -5063,7 +5063,7 @@
           <p:cNvPr id="10" name="proxy-b-1">
             <a:extLst xmlns:a="http://schemas.openxmlformats.org/drawingml/2006/main">
               <a:ext uri="{FF2B5EF4-FFF2-40B4-BE49-F238E27FC236}">
-                <a16:creationId xmlns:a16="http://schemas.microsoft.com/office/drawing/2014/main" id="{43F5ADA0-8547-4349-A117-8212B6A4FBC5}"/>
+                <a16:creationId xmlns:a16="http://schemas.microsoft.com/office/drawing/2014/main" id="{607AC531-1522-4627-931B-0DD4432FD68A}"/>
               </a:ext>
             </a:extLst>
           </p:cNvPr>
@@ -5113,7 +5113,7 @@
           <p:cNvPr id="11" name="proxy-b-2">
             <a:extLst xmlns:a="http://schemas.openxmlformats.org/drawingml/2006/main">
               <a:ext uri="{FF2B5EF4-FFF2-40B4-BE49-F238E27FC236}">
-                <a16:creationId xmlns:a16="http://schemas.microsoft.com/office/drawing/2014/main" id="{304AD1B1-A071-44BE-9931-BA504F811B1F}"/>
+                <a16:creationId xmlns:a16="http://schemas.microsoft.com/office/drawing/2014/main" id="{AFBF2733-3448-432E-A58A-447F13AFF512}"/>
               </a:ext>
             </a:extLst>
           </p:cNvPr>
@@ -5163,7 +5163,7 @@
           <p:cNvPr id="12" name="live-pill-bg">
             <a:extLst xmlns:a="http://schemas.openxmlformats.org/drawingml/2006/main">
               <a:ext uri="{FF2B5EF4-FFF2-40B4-BE49-F238E27FC236}">
-                <a16:creationId xmlns:a16="http://schemas.microsoft.com/office/drawing/2014/main" id="{53D863D2-F4E5-4713-A324-35178AAC7AEA}"/>
+                <a16:creationId xmlns:a16="http://schemas.microsoft.com/office/drawing/2014/main" id="{62D66332-6798-428B-9B58-CD295A32DE52}"/>
               </a:ext>
             </a:extLst>
           </p:cNvPr>
@@ -5196,7 +5196,7 @@
           <p:cNvPr id="13" name="live-pill-txt">
             <a:extLst xmlns:a="http://schemas.openxmlformats.org/drawingml/2006/main">
               <a:ext uri="{FF2B5EF4-FFF2-40B4-BE49-F238E27FC236}">
-                <a16:creationId xmlns:a16="http://schemas.microsoft.com/office/drawing/2014/main" id="{6B66981B-6171-4BFE-B0D1-575B23E638C1}"/>
+                <a16:creationId xmlns:a16="http://schemas.microsoft.com/office/drawing/2014/main" id="{B7F0B26E-7CCB-4594-AF3C-E29C7FC5D9F0}"/>
               </a:ext>
             </a:extLst>
           </p:cNvPr>
@@ -5246,7 +5246,7 @@
           <p:cNvPr id="14" name="live-title">
             <a:extLst xmlns:a="http://schemas.openxmlformats.org/drawingml/2006/main">
               <a:ext uri="{FF2B5EF4-FFF2-40B4-BE49-F238E27FC236}">
-                <a16:creationId xmlns:a16="http://schemas.microsoft.com/office/drawing/2014/main" id="{06285FB2-C92D-4016-A881-9961BD18BC7A}"/>
+                <a16:creationId xmlns:a16="http://schemas.microsoft.com/office/drawing/2014/main" id="{1700DA65-845C-4D49-B68C-1F886DCB3D95}"/>
               </a:ext>
             </a:extLst>
           </p:cNvPr>
@@ -5296,7 +5296,7 @@
           <p:cNvPr id="15" name="live-b-0">
             <a:extLst xmlns:a="http://schemas.openxmlformats.org/drawingml/2006/main">
               <a:ext uri="{FF2B5EF4-FFF2-40B4-BE49-F238E27FC236}">
-                <a16:creationId xmlns:a16="http://schemas.microsoft.com/office/drawing/2014/main" id="{1FBB9B85-F0C9-48F1-ABCD-83F9B9EE4322}"/>
+                <a16:creationId xmlns:a16="http://schemas.microsoft.com/office/drawing/2014/main" id="{01981913-DF92-42AE-AA28-F696D06A0AED}"/>
               </a:ext>
             </a:extLst>
           </p:cNvPr>
@@ -5346,7 +5346,7 @@
           <p:cNvPr id="16" name="live-b-1">
             <a:extLst xmlns:a="http://schemas.openxmlformats.org/drawingml/2006/main">
               <a:ext uri="{FF2B5EF4-FFF2-40B4-BE49-F238E27FC236}">
-                <a16:creationId xmlns:a16="http://schemas.microsoft.com/office/drawing/2014/main" id="{AC04C07F-D988-443E-A61F-360695EC52CC}"/>
+                <a16:creationId xmlns:a16="http://schemas.microsoft.com/office/drawing/2014/main" id="{1929B473-8D07-4C40-8E90-C31C4419D851}"/>
               </a:ext>
             </a:extLst>
           </p:cNvPr>
@@ -5396,7 +5396,7 @@
           <p:cNvPr id="17" name="live-b-2">
             <a:extLst xmlns:a="http://schemas.openxmlformats.org/drawingml/2006/main">
               <a:ext uri="{FF2B5EF4-FFF2-40B4-BE49-F238E27FC236}">
-                <a16:creationId xmlns:a16="http://schemas.microsoft.com/office/drawing/2014/main" id="{57C9FE5E-32C7-4A28-817F-ED7598E95BCE}"/>
+                <a16:creationId xmlns:a16="http://schemas.microsoft.com/office/drawing/2014/main" id="{98E2D63A-225F-4CA4-89B2-F052C0E90907}"/>
               </a:ext>
             </a:extLst>
           </p:cNvPr>
@@ -5446,7 +5446,7 @@
           <p:cNvPr id="18" name="bridge">
             <a:extLst xmlns:a="http://schemas.openxmlformats.org/drawingml/2006/main">
               <a:ext uri="{FF2B5EF4-FFF2-40B4-BE49-F238E27FC236}">
-                <a16:creationId xmlns:a16="http://schemas.microsoft.com/office/drawing/2014/main" id="{5A9329D3-328D-47F7-89C4-EE32F39BB17F}"/>
+                <a16:creationId xmlns:a16="http://schemas.microsoft.com/office/drawing/2014/main" id="{D2D8866D-D04C-4ACA-AFBE-37D528F2C642}"/>
               </a:ext>
             </a:extLst>
           </p:cNvPr>
@@ -5496,7 +5496,7 @@
           <p:cNvPr id="19" name="footer-left">
             <a:extLst xmlns:a="http://schemas.openxmlformats.org/drawingml/2006/main">
               <a:ext uri="{FF2B5EF4-FFF2-40B4-BE49-F238E27FC236}">
-                <a16:creationId xmlns:a16="http://schemas.microsoft.com/office/drawing/2014/main" id="{83C1125F-F375-45F3-A47A-3129FF939358}"/>
+                <a16:creationId xmlns:a16="http://schemas.microsoft.com/office/drawing/2014/main" id="{7D03AACB-7AC8-4E8D-A104-F6C0BB2A03D6}"/>
               </a:ext>
             </a:extLst>
           </p:cNvPr>
@@ -5546,7 +5546,7 @@
           <p:cNvPr id="20" name="footer-right">
             <a:extLst xmlns:a="http://schemas.openxmlformats.org/drawingml/2006/main">
               <a:ext uri="{FF2B5EF4-FFF2-40B4-BE49-F238E27FC236}">
-                <a16:creationId xmlns:a16="http://schemas.microsoft.com/office/drawing/2014/main" id="{A2EBFB99-1AD1-4FF4-9CDD-D6ADB8959E3D}"/>
+                <a16:creationId xmlns:a16="http://schemas.microsoft.com/office/drawing/2014/main" id="{E54BB6D4-6B43-422F-B68C-57580D8E0DE7}"/>
               </a:ext>
             </a:extLst>
           </p:cNvPr>
@@ -5594,7 +5594,7 @@
     </p:spTree>
     <p:extLst>
       <p:ext uri="{BB962C8B-B14F-4D97-AF65-F5344CB8AC3E}">
-        <p14:creationId xmlns:p14="http://schemas.microsoft.com/office/powerpoint/2010/main" val="631552282"/>
+        <p14:creationId xmlns:p14="http://schemas.microsoft.com/office/powerpoint/2010/main" val="2051651181"/>
       </p:ext>
     </p:extLst>
   </p:cSld>
@@ -5625,7 +5625,7 @@
           <p:cNvPr id="1" name="kicker">
             <a:extLst xmlns:a="http://schemas.openxmlformats.org/drawingml/2006/main">
               <a:ext uri="{FF2B5EF4-FFF2-40B4-BE49-F238E27FC236}">
-                <a16:creationId xmlns:a16="http://schemas.microsoft.com/office/drawing/2014/main" id="{EF1B36A0-658C-4E70-B238-476CE4A91445}"/>
+                <a16:creationId xmlns:a16="http://schemas.microsoft.com/office/drawing/2014/main" id="{7C59DED4-CAAB-49D0-99B6-A184F2AF0376}"/>
               </a:ext>
             </a:extLst>
           </p:cNvPr>
@@ -5675,7 +5675,7 @@
           <p:cNvPr id="2" name="slide-title">
             <a:extLst xmlns:a="http://schemas.openxmlformats.org/drawingml/2006/main">
               <a:ext uri="{FF2B5EF4-FFF2-40B4-BE49-F238E27FC236}">
-                <a16:creationId xmlns:a16="http://schemas.microsoft.com/office/drawing/2014/main" id="{2631E327-A74F-4A40-B1CA-50F0A13BE439}"/>
+                <a16:creationId xmlns:a16="http://schemas.microsoft.com/office/drawing/2014/main" id="{8CA56763-E2D0-4775-8F9C-BFA37B95D8EF}"/>
               </a:ext>
             </a:extLst>
           </p:cNvPr>
@@ -5725,7 +5725,7 @@
           <p:cNvPr id="3" name="rule">
             <a:extLst xmlns:a="http://schemas.openxmlformats.org/drawingml/2006/main">
               <a:ext uri="{FF2B5EF4-FFF2-40B4-BE49-F238E27FC236}">
-                <a16:creationId xmlns:a16="http://schemas.microsoft.com/office/drawing/2014/main" id="{EF6DCC0D-42BD-42CC-9CDE-A57280EC2F4C}"/>
+                <a16:creationId xmlns:a16="http://schemas.microsoft.com/office/drawing/2014/main" id="{A6DCE94F-5601-4FCA-A315-6A54F2659FE4}"/>
               </a:ext>
             </a:extLst>
           </p:cNvPr>
@@ -5758,7 +5758,7 @@
           <p:cNvPr id="4" name="recommend">
             <a:extLst xmlns:a="http://schemas.openxmlformats.org/drawingml/2006/main">
               <a:ext uri="{FF2B5EF4-FFF2-40B4-BE49-F238E27FC236}">
-                <a16:creationId xmlns:a16="http://schemas.microsoft.com/office/drawing/2014/main" id="{3153BD63-0EE9-443F-969F-28A92D91E3BD}"/>
+                <a16:creationId xmlns:a16="http://schemas.microsoft.com/office/drawing/2014/main" id="{695636AF-8EA3-406B-9AD4-26CC7C59EE56}"/>
               </a:ext>
             </a:extLst>
           </p:cNvPr>
@@ -5791,7 +5791,7 @@
           <p:cNvPr id="5" name="rec-title">
             <a:extLst xmlns:a="http://schemas.openxmlformats.org/drawingml/2006/main">
               <a:ext uri="{FF2B5EF4-FFF2-40B4-BE49-F238E27FC236}">
-                <a16:creationId xmlns:a16="http://schemas.microsoft.com/office/drawing/2014/main" id="{4FA3027D-ABFF-430D-9C9C-FFBC2A626793}"/>
+                <a16:creationId xmlns:a16="http://schemas.microsoft.com/office/drawing/2014/main" id="{8846FA6F-CAB4-4C72-942E-73F0E9618622}"/>
               </a:ext>
             </a:extLst>
           </p:cNvPr>
@@ -5841,7 +5841,7 @@
           <p:cNvPr id="6" name="rec-b-0">
             <a:extLst xmlns:a="http://schemas.openxmlformats.org/drawingml/2006/main">
               <a:ext uri="{FF2B5EF4-FFF2-40B4-BE49-F238E27FC236}">
-                <a16:creationId xmlns:a16="http://schemas.microsoft.com/office/drawing/2014/main" id="{A4A375BF-092B-4537-9EC1-F0ACFE6D7522}"/>
+                <a16:creationId xmlns:a16="http://schemas.microsoft.com/office/drawing/2014/main" id="{2FFC75D3-4C08-4D55-B8BF-30E49C09ACA4}"/>
               </a:ext>
             </a:extLst>
           </p:cNvPr>
@@ -5891,7 +5891,7 @@
           <p:cNvPr id="7" name="rec-b-1">
             <a:extLst xmlns:a="http://schemas.openxmlformats.org/drawingml/2006/main">
               <a:ext uri="{FF2B5EF4-FFF2-40B4-BE49-F238E27FC236}">
-                <a16:creationId xmlns:a16="http://schemas.microsoft.com/office/drawing/2014/main" id="{18FB8F94-B96B-441D-923D-DDC3D9205BF2}"/>
+                <a16:creationId xmlns:a16="http://schemas.microsoft.com/office/drawing/2014/main" id="{ADB5AB00-70CE-4D70-98F9-5F105AEA3557}"/>
               </a:ext>
             </a:extLst>
           </p:cNvPr>
@@ -5931,7 +5931,7 @@
                   <a:srgbClr val="000000"/>
                 </a:solidFill>
               </a:rPr>
-              <a:t>- Compare direct-spec versus Gen4-faithful pooled-family under identical true live-capital accounting.</a:t>
+              <a:t>- Compare direct-spec versus pooled-family under shared Gen5.2 eligibility, scoring, and true live-capital accounting.</a:t>
             </a:r>
           </a:p>
         </p:txBody>
@@ -5941,7 +5941,7 @@
           <p:cNvPr id="8" name="rec-b-2">
             <a:extLst xmlns:a="http://schemas.openxmlformats.org/drawingml/2006/main">
               <a:ext uri="{FF2B5EF4-FFF2-40B4-BE49-F238E27FC236}">
-                <a16:creationId xmlns:a16="http://schemas.microsoft.com/office/drawing/2014/main" id="{7B5B4052-93A8-4265-ADCF-A85E5FBDD0B5}"/>
+                <a16:creationId xmlns:a16="http://schemas.microsoft.com/office/drawing/2014/main" id="{B11B1441-A734-473B-8209-9C624D1B59C1}"/>
               </a:ext>
             </a:extLst>
           </p:cNvPr>
@@ -5991,7 +5991,7 @@
           <p:cNvPr id="9" name="stops">
             <a:extLst xmlns:a="http://schemas.openxmlformats.org/drawingml/2006/main">
               <a:ext uri="{FF2B5EF4-FFF2-40B4-BE49-F238E27FC236}">
-                <a16:creationId xmlns:a16="http://schemas.microsoft.com/office/drawing/2014/main" id="{ED2BA9B9-B1E7-4FEA-9426-8B6299CB9560}"/>
+                <a16:creationId xmlns:a16="http://schemas.microsoft.com/office/drawing/2014/main" id="{A0C01C7A-F3CA-4C37-A0E5-E939A628EE5B}"/>
               </a:ext>
             </a:extLst>
           </p:cNvPr>
@@ -6024,7 +6024,7 @@
           <p:cNvPr id="10" name="stop-title">
             <a:extLst xmlns:a="http://schemas.openxmlformats.org/drawingml/2006/main">
               <a:ext uri="{FF2B5EF4-FFF2-40B4-BE49-F238E27FC236}">
-                <a16:creationId xmlns:a16="http://schemas.microsoft.com/office/drawing/2014/main" id="{79E1B2EF-1656-4D5C-A8B7-81BA8DB3AE77}"/>
+                <a16:creationId xmlns:a16="http://schemas.microsoft.com/office/drawing/2014/main" id="{67D51263-82D2-41B6-819D-B3C8FCB496FC}"/>
               </a:ext>
             </a:extLst>
           </p:cNvPr>
@@ -6074,7 +6074,7 @@
           <p:cNvPr id="11" name="stop-b-0">
             <a:extLst xmlns:a="http://schemas.openxmlformats.org/drawingml/2006/main">
               <a:ext uri="{FF2B5EF4-FFF2-40B4-BE49-F238E27FC236}">
-                <a16:creationId xmlns:a16="http://schemas.microsoft.com/office/drawing/2014/main" id="{0ECA51E1-F72B-4DC6-A7E4-A22F404BFAA6}"/>
+                <a16:creationId xmlns:a16="http://schemas.microsoft.com/office/drawing/2014/main" id="{4E864BE3-994E-4204-BE1B-AEEC8216C912}"/>
               </a:ext>
             </a:extLst>
           </p:cNvPr>
@@ -6124,7 +6124,7 @@
           <p:cNvPr id="12" name="stop-b-1">
             <a:extLst xmlns:a="http://schemas.openxmlformats.org/drawingml/2006/main">
               <a:ext uri="{FF2B5EF4-FFF2-40B4-BE49-F238E27FC236}">
-                <a16:creationId xmlns:a16="http://schemas.microsoft.com/office/drawing/2014/main" id="{D990E26A-FAC4-4C9F-83E0-29098D97C2A7}"/>
+                <a16:creationId xmlns:a16="http://schemas.microsoft.com/office/drawing/2014/main" id="{7BF6F292-678B-4609-BC8E-21EB54259727}"/>
               </a:ext>
             </a:extLst>
           </p:cNvPr>
@@ -6174,7 +6174,7 @@
           <p:cNvPr id="13" name="stop-b-2">
             <a:extLst xmlns:a="http://schemas.openxmlformats.org/drawingml/2006/main">
               <a:ext uri="{FF2B5EF4-FFF2-40B4-BE49-F238E27FC236}">
-                <a16:creationId xmlns:a16="http://schemas.microsoft.com/office/drawing/2014/main" id="{31A4BA7B-6261-46BF-84E6-94BE65E6A771}"/>
+                <a16:creationId xmlns:a16="http://schemas.microsoft.com/office/drawing/2014/main" id="{61605314-BC8A-471A-94A1-1B04EC82C32E}"/>
               </a:ext>
             </a:extLst>
           </p:cNvPr>
@@ -6224,7 +6224,7 @@
           <p:cNvPr id="14" name="rule">
             <a:extLst xmlns:a="http://schemas.openxmlformats.org/drawingml/2006/main">
               <a:ext uri="{FF2B5EF4-FFF2-40B4-BE49-F238E27FC236}">
-                <a16:creationId xmlns:a16="http://schemas.microsoft.com/office/drawing/2014/main" id="{390F2579-0918-4691-AFAD-D7876A31FE8E}"/>
+                <a16:creationId xmlns:a16="http://schemas.microsoft.com/office/drawing/2014/main" id="{E759B2C2-EF80-47FD-8779-F52BA233CC60}"/>
               </a:ext>
             </a:extLst>
           </p:cNvPr>
@@ -6257,7 +6257,7 @@
           <p:cNvPr id="15" name="close">
             <a:extLst xmlns:a="http://schemas.openxmlformats.org/drawingml/2006/main">
               <a:ext uri="{FF2B5EF4-FFF2-40B4-BE49-F238E27FC236}">
-                <a16:creationId xmlns:a16="http://schemas.microsoft.com/office/drawing/2014/main" id="{6F177A4B-08F1-45C5-9939-FEFCF5F623B5}"/>
+                <a16:creationId xmlns:a16="http://schemas.microsoft.com/office/drawing/2014/main" id="{E4D60FF2-1A25-41A0-9236-CF92993B2E93}"/>
               </a:ext>
             </a:extLst>
           </p:cNvPr>
@@ -6307,7 +6307,7 @@
           <p:cNvPr id="16" name="footer-left">
             <a:extLst xmlns:a="http://schemas.openxmlformats.org/drawingml/2006/main">
               <a:ext uri="{FF2B5EF4-FFF2-40B4-BE49-F238E27FC236}">
-                <a16:creationId xmlns:a16="http://schemas.microsoft.com/office/drawing/2014/main" id="{B3F289A1-D812-4DFB-8A71-32949886FDCB}"/>
+                <a16:creationId xmlns:a16="http://schemas.microsoft.com/office/drawing/2014/main" id="{178C1942-0434-4B35-B7C9-AE87F2BAF8DD}"/>
               </a:ext>
             </a:extLst>
           </p:cNvPr>
@@ -6357,7 +6357,7 @@
           <p:cNvPr id="17" name="footer-right">
             <a:extLst xmlns:a="http://schemas.openxmlformats.org/drawingml/2006/main">
               <a:ext uri="{FF2B5EF4-FFF2-40B4-BE49-F238E27FC236}">
-                <a16:creationId xmlns:a16="http://schemas.microsoft.com/office/drawing/2014/main" id="{F340F469-96DD-4910-94FE-BD140339D591}"/>
+                <a16:creationId xmlns:a16="http://schemas.microsoft.com/office/drawing/2014/main" id="{9F508576-A778-41DA-8FF3-9CB5441E1E31}"/>
               </a:ext>
             </a:extLst>
           </p:cNvPr>
@@ -6405,7 +6405,7 @@
     </p:spTree>
     <p:extLst>
       <p:ext uri="{BB962C8B-B14F-4D97-AF65-F5344CB8AC3E}">
-        <p14:creationId xmlns:p14="http://schemas.microsoft.com/office/powerpoint/2010/main" val="1745267224"/>
+        <p14:creationId xmlns:p14="http://schemas.microsoft.com/office/powerpoint/2010/main" val="1993122148"/>
       </p:ext>
     </p:extLst>
   </p:cSld>

</xml_diff>